<commit_message>
Update overall progress slide with latest document status
Record cleaning philosophy and operating manual out for cross-discipline review, checked datasheets issuing 12 Aug, and the R24-CR01 change-impact document list.

Co-authored-by: peterli0913 <peterli0913@users.noreply.github.com>
</commit_message>
<xml_diff>
--- a/Progress_Report_0811.pptx
+++ b/Progress_Report_0811.pptx
@@ -3320,7 +3320,7 @@
         <p:spPr>
           <a:xfrm>
             <a:off x="640080" y="1920240"/>
-            <a:ext cx="10972800" cy="1700784"/>
+            <a:ext cx="10972800" cy="2084831"/>
           </a:xfrm>
           <a:prstGeom prst="rect">
             <a:avLst/>
@@ -3351,7 +3351,7 @@
                 <a:latin typeface="Segoe UI"/>
                 <a:ea typeface="Microsoft YaHei"/>
               </a:rPr>
-              <a:t>Design package closing out — internal cross-review complete, issue to SW next Tuesday</a:t>
+              <a:t>Design package closing out — documents moving through internal review to issue</a:t>
             </a:r>
           </a:p>
           <a:p>
@@ -3368,7 +3368,7 @@
                 <a:latin typeface="Microsoft YaHei"/>
                 <a:ea typeface="Microsoft YaHei"/>
               </a:rPr>
-              <a:t>     设计文件收口，国内内部会审完成，下周二发出 SW</a:t>
+              <a:t>     设计文件收口，各文件正由内部会审转入正式发出</a:t>
             </a:r>
           </a:p>
           <a:p>
@@ -3395,7 +3395,7 @@
                 <a:latin typeface="Segoe UI"/>
                 <a:ea typeface="Microsoft YaHei"/>
               </a:rPr>
-              <a:t>Cleaning philosophy · 3D layout · control philosophy</a:t>
+              <a:t>Updated cleaning philosophy and operating manual issued for cross-discipline review</a:t>
             </a:r>
           </a:p>
           <a:p>
@@ -3407,7 +3407,7 @@
                 <a:latin typeface="Microsoft YaHei"/>
                 <a:ea typeface="Microsoft YaHei"/>
               </a:rPr>
-              <a:t>             清洗方案 · 3D 布置 · 控制说明</a:t>
+              <a:t>             更新的清洗说明与操作手册已发各专业会审</a:t>
             </a:r>
           </a:p>
           <a:p>
@@ -3434,7 +3434,7 @@
                 <a:latin typeface="Segoe UI"/>
                 <a:ea typeface="Microsoft YaHei"/>
               </a:rPr>
-              <a:t>Equipment datasheets reissued at 75 barg / CLASS 900</a:t>
+              <a:t>Reissued equipment and instrument datasheets checked — issue on the morning of 12 Aug</a:t>
             </a:r>
           </a:p>
           <a:p>
@@ -3446,7 +3446,7 @@
                 <a:latin typeface="Microsoft YaHei"/>
                 <a:ea typeface="Microsoft YaHei"/>
               </a:rPr>
-              <a:t>             设备数据单按 75 barg / CLASS 900 升版</a:t>
+              <a:t>             升版的设备数据单与仪表数据单已校核完成，8/12 上午发出</a:t>
             </a:r>
           </a:p>
           <a:p>
@@ -3473,7 +3473,7 @@
                 <a:latin typeface="Segoe UI"/>
                 <a:ea typeface="Microsoft YaHei"/>
               </a:rPr>
-              <a:t>Instrument datasheets 11 Aug · operating manual first issue</a:t>
+              <a:t>Document list affected by the R24-CR01 size change — issue expected on the morning of 12 Aug</a:t>
             </a:r>
           </a:p>
           <a:p>
@@ -3485,7 +3485,46 @@
                 <a:latin typeface="Microsoft YaHei"/>
                 <a:ea typeface="Microsoft YaHei"/>
               </a:rPr>
-              <a:t>             仪表数据表 8/11 · 操作手册初稿本周发出</a:t>
+              <a:t>             因 R24-CR01 尺寸变更需更新的文件清单，预计 8/12 上午发出</a:t>
+            </a:r>
+          </a:p>
+          <a:p>
+            <a:pPr>
+              <a:spcBef>
+                <a:spcPts val="400"/>
+              </a:spcBef>
+            </a:pPr>
+            <a:r>
+              <a:rPr sz="1400" b="0">
+                <a:solidFill>
+                  <a:srgbClr val="B7C0CF"/>
+                </a:solidFill>
+                <a:latin typeface="Segoe UI"/>
+                <a:ea typeface="Microsoft YaHei"/>
+              </a:rPr>
+              <a:t>        –  </a:t>
+            </a:r>
+            <a:r>
+              <a:rPr sz="1400" b="0">
+                <a:solidFill>
+                  <a:srgbClr val="3C4A5A"/>
+                </a:solidFill>
+                <a:latin typeface="Segoe UI"/>
+                <a:ea typeface="Microsoft YaHei"/>
+              </a:rPr>
+              <a:t>Cleaning philosophy · 3D layout · control philosophy to SW next Tuesday</a:t>
+            </a:r>
+          </a:p>
+          <a:p>
+            <a:r>
+              <a:rPr sz="1050" b="0">
+                <a:solidFill>
+                  <a:srgbClr val="8A97AB"/>
+                </a:solidFill>
+                <a:latin typeface="Microsoft YaHei"/>
+                <a:ea typeface="Microsoft YaHei"/>
+              </a:rPr>
+              <a:t>             清洗方案 · 3D 布置 · 控制说明，下周二发出 SW</a:t>
             </a:r>
           </a:p>
         </p:txBody>
@@ -3498,7 +3537,7 @@
         </p:nvSpPr>
         <p:spPr>
           <a:xfrm>
-            <a:off x="640080" y="3822191"/>
+            <a:off x="640080" y="4206240"/>
             <a:ext cx="10972800" cy="548640"/>
           </a:xfrm>
           <a:prstGeom prst="rect">
@@ -3560,7 +3599,7 @@
         </p:nvSpPr>
         <p:spPr>
           <a:xfrm>
-            <a:off x="640080" y="4572000"/>
+            <a:off x="640080" y="4956048"/>
             <a:ext cx="10972800" cy="548640"/>
           </a:xfrm>
           <a:prstGeom prst="rect">
@@ -3622,7 +3661,7 @@
         </p:nvSpPr>
         <p:spPr>
           <a:xfrm>
-            <a:off x="640080" y="5321808"/>
+            <a:off x="640080" y="5705856"/>
             <a:ext cx="10972800" cy="548640"/>
           </a:xfrm>
           <a:prstGeom prst="rect">

</xml_diff>